<commit_message>
chore: convert lecture materials to PDF and update course links
</commit_message>
<xml_diff>
--- a/data/인공지능/00-preview.pptx
+++ b/data/인공지능/00-preview.pptx
@@ -7,6 +7,9 @@
   <p:notesMasterIdLst>
     <p:notesMasterId r:id="rId9"/>
   </p:notesMasterIdLst>
+  <p:handoutMasterIdLst>
+    <p:handoutMasterId r:id="rId10"/>
+  </p:handoutMasterIdLst>
   <p:sldIdLst>
     <p:sldId id="257" r:id="rId2"/>
     <p:sldId id="303" r:id="rId3"/>
@@ -21,20 +24,20 @@
   <p:embeddedFontLst>
     <p:embeddedFont>
       <p:font typeface="Malgun Gothic" panose="020B0503020000020004" pitchFamily="50" charset="-127"/>
-      <p:regular r:id="rId10"/>
-      <p:bold r:id="rId11"/>
+      <p:regular r:id="rId11"/>
+      <p:bold r:id="rId12"/>
     </p:embeddedFont>
     <p:embeddedFont>
       <p:font typeface="Calibri" panose="020F0502020204030204" pitchFamily="34" charset="0"/>
-      <p:regular r:id="rId12"/>
-      <p:bold r:id="rId13"/>
-      <p:italic r:id="rId14"/>
-      <p:boldItalic r:id="rId15"/>
+      <p:regular r:id="rId13"/>
+      <p:bold r:id="rId14"/>
+      <p:italic r:id="rId15"/>
+      <p:boldItalic r:id="rId16"/>
     </p:embeddedFont>
     <p:embeddedFont>
       <p:font typeface="Noto Sans Symbols" pitchFamily="2" charset="0"/>
-      <p:regular r:id="rId16"/>
-      <p:bold r:id="rId17"/>
+      <p:regular r:id="rId17"/>
+      <p:bold r:id="rId18"/>
     </p:embeddedFont>
   </p:embeddedFontLst>
   <p:defaultTextStyle>
@@ -331,10 +334,199 @@
       </p15:notesGuideLst>
     </p:ext>
     <p:ext uri="GoogleSlidesCustomDataVersion2">
-      <go:slidesCustomData xmlns:go="http://customooxmlschemas.google.com/" xmlns:ahyp="http://schemas.microsoft.com/office/drawing/2018/hyperlinkcolor" xmlns:p15="http://schemas.microsoft.com/office/powerpoint/2012/main" xmlns:p14="http://schemas.microsoft.com/office/powerpoint/2010/main" xmlns:com="http://schemas.openxmlformats.org/drawingml/2006/compatibility" xmlns:pvml="urn:schemas-microsoft-com:office:powerpoint" xmlns:v="urn:schemas-microsoft-com:vml" xmlns:o="urn:schemas-microsoft-com:office:office" xmlns:dgm="http://schemas.openxmlformats.org/drawingml/2006/diagram" xmlns:c="http://schemas.openxmlformats.org/drawingml/2006/chart" xmlns:mv="urn:schemas-microsoft-com:mac:vml" xmlns:mc="http://schemas.openxmlformats.org/markup-compatibility/2006" xmlns="" r:id="rId61" roundtripDataSignature="AMtx7mgQh/JTZB+tcnoesXfhZuEldfv5OQ=="/>
+      <go:slidesCustomData xmlns="" xmlns:mc="http://schemas.openxmlformats.org/markup-compatibility/2006" xmlns:mv="urn:schemas-microsoft-com:mac:vml" xmlns:c="http://schemas.openxmlformats.org/drawingml/2006/chart" xmlns:dgm="http://schemas.openxmlformats.org/drawingml/2006/diagram" xmlns:o="urn:schemas-microsoft-com:office:office" xmlns:v="urn:schemas-microsoft-com:vml" xmlns:pvml="urn:schemas-microsoft-com:office:powerpoint" xmlns:com="http://schemas.openxmlformats.org/drawingml/2006/compatibility" xmlns:p14="http://schemas.microsoft.com/office/powerpoint/2010/main" xmlns:p15="http://schemas.microsoft.com/office/powerpoint/2012/main" xmlns:ahyp="http://schemas.microsoft.com/office/drawing/2018/hyperlinkcolor" xmlns:go="http://customooxmlschemas.google.com/" r:id="rId61" roundtripDataSignature="AMtx7mgQh/JTZB+tcnoesXfhZuEldfv5OQ=="/>
     </p:ext>
   </p:extLst>
 </p:presentation>
+</file>
+
+<file path=ppt/handoutMasters/handoutMaster1.xml><?xml version="1.0" encoding="utf-8"?>
+<p:handoutMaster xmlns:a="http://schemas.openxmlformats.org/drawingml/2006/main" xmlns:r="http://schemas.openxmlformats.org/officeDocument/2006/relationships" xmlns:p="http://schemas.openxmlformats.org/presentationml/2006/main">
+  <p:cSld>
+    <p:bg>
+      <p:bgRef idx="1001">
+        <a:schemeClr val="bg1"/>
+      </p:bgRef>
+    </p:bg>
+    <p:spTree>
+      <p:nvGrpSpPr>
+        <p:cNvPr id="1" name=""/>
+        <p:cNvGrpSpPr/>
+        <p:nvPr/>
+      </p:nvGrpSpPr>
+      <p:grpSpPr>
+        <a:xfrm>
+          <a:off x="0" y="0"/>
+          <a:ext cx="0" cy="0"/>
+          <a:chOff x="0" y="0"/>
+          <a:chExt cx="0" cy="0"/>
+        </a:xfrm>
+      </p:grpSpPr>
+      <p:sp>
+        <p:nvSpPr>
+          <p:cNvPr id="2" name="머리글 개체 틀 1">
+            <a:extLst>
+              <a:ext uri="{FF2B5EF4-FFF2-40B4-BE49-F238E27FC236}">
+                <a16:creationId xmlns:a16="http://schemas.microsoft.com/office/drawing/2014/main" id="{8B53A62B-0119-430B-82FE-D03910B655BD}"/>
+              </a:ext>
+            </a:extLst>
+          </p:cNvPr>
+          <p:cNvSpPr>
+            <a:spLocks noGrp="1"/>
+          </p:cNvSpPr>
+          <p:nvPr>
+            <p:ph type="hdr" sz="quarter"/>
+          </p:nvPr>
+        </p:nvSpPr>
+        <p:spPr>
+          <a:xfrm>
+            <a:off x="0" y="0"/>
+            <a:ext cx="2971800" cy="458788"/>
+          </a:xfrm>
+          <a:prstGeom prst="rect">
+            <a:avLst/>
+          </a:prstGeom>
+        </p:spPr>
+        <p:txBody>
+          <a:bodyPr vert="horz" lIns="91440" tIns="45720" rIns="91440" bIns="45720" rtlCol="0"/>
+          <a:lstStyle>
+            <a:lvl1pPr algn="l">
+              <a:defRPr sz="1200"/>
+            </a:lvl1pPr>
+          </a:lstStyle>
+          <a:p>
+            <a:endParaRPr lang="ko-KR" altLang="en-US"/>
+          </a:p>
+        </p:txBody>
+      </p:sp>
+      <p:sp>
+        <p:nvSpPr>
+          <p:cNvPr id="3" name="날짜 개체 틀 2">
+            <a:extLst>
+              <a:ext uri="{FF2B5EF4-FFF2-40B4-BE49-F238E27FC236}">
+                <a16:creationId xmlns:a16="http://schemas.microsoft.com/office/drawing/2014/main" id="{73AE823F-FA38-4333-87AC-535E0D4C6305}"/>
+              </a:ext>
+            </a:extLst>
+          </p:cNvPr>
+          <p:cNvSpPr>
+            <a:spLocks noGrp="1"/>
+          </p:cNvSpPr>
+          <p:nvPr>
+            <p:ph type="dt" sz="quarter" idx="1"/>
+          </p:nvPr>
+        </p:nvSpPr>
+        <p:spPr>
+          <a:xfrm>
+            <a:off x="3884613" y="0"/>
+            <a:ext cx="2971800" cy="458788"/>
+          </a:xfrm>
+          <a:prstGeom prst="rect">
+            <a:avLst/>
+          </a:prstGeom>
+        </p:spPr>
+        <p:txBody>
+          <a:bodyPr vert="horz" lIns="91440" tIns="45720" rIns="91440" bIns="45720" rtlCol="0"/>
+          <a:lstStyle>
+            <a:lvl1pPr algn="r">
+              <a:defRPr sz="1200"/>
+            </a:lvl1pPr>
+          </a:lstStyle>
+          <a:p>
+            <a:fld id="{33DE9E9F-7079-4910-908C-9BA5352E9677}" type="datetimeFigureOut">
+              <a:rPr lang="ko-KR" altLang="en-US" smtClean="0"/>
+              <a:t>2026-03-02</a:t>
+            </a:fld>
+            <a:endParaRPr lang="ko-KR" altLang="en-US"/>
+          </a:p>
+        </p:txBody>
+      </p:sp>
+      <p:sp>
+        <p:nvSpPr>
+          <p:cNvPr id="4" name="바닥글 개체 틀 3">
+            <a:extLst>
+              <a:ext uri="{FF2B5EF4-FFF2-40B4-BE49-F238E27FC236}">
+                <a16:creationId xmlns:a16="http://schemas.microsoft.com/office/drawing/2014/main" id="{B4886587-21D4-47D6-A830-4F9CDD5129A5}"/>
+              </a:ext>
+            </a:extLst>
+          </p:cNvPr>
+          <p:cNvSpPr>
+            <a:spLocks noGrp="1"/>
+          </p:cNvSpPr>
+          <p:nvPr>
+            <p:ph type="ftr" sz="quarter" idx="2"/>
+          </p:nvPr>
+        </p:nvSpPr>
+        <p:spPr>
+          <a:xfrm>
+            <a:off x="0" y="8685213"/>
+            <a:ext cx="2971800" cy="458787"/>
+          </a:xfrm>
+          <a:prstGeom prst="rect">
+            <a:avLst/>
+          </a:prstGeom>
+        </p:spPr>
+        <p:txBody>
+          <a:bodyPr vert="horz" lIns="91440" tIns="45720" rIns="91440" bIns="45720" rtlCol="0" anchor="b"/>
+          <a:lstStyle>
+            <a:lvl1pPr algn="l">
+              <a:defRPr sz="1200"/>
+            </a:lvl1pPr>
+          </a:lstStyle>
+          <a:p>
+            <a:endParaRPr lang="ko-KR" altLang="en-US"/>
+          </a:p>
+        </p:txBody>
+      </p:sp>
+      <p:sp>
+        <p:nvSpPr>
+          <p:cNvPr id="5" name="슬라이드 번호 개체 틀 4">
+            <a:extLst>
+              <a:ext uri="{FF2B5EF4-FFF2-40B4-BE49-F238E27FC236}">
+                <a16:creationId xmlns:a16="http://schemas.microsoft.com/office/drawing/2014/main" id="{A696394F-E017-43D0-B920-8CE1F50B6690}"/>
+              </a:ext>
+            </a:extLst>
+          </p:cNvPr>
+          <p:cNvSpPr>
+            <a:spLocks noGrp="1"/>
+          </p:cNvSpPr>
+          <p:nvPr>
+            <p:ph type="sldNum" sz="quarter" idx="3"/>
+          </p:nvPr>
+        </p:nvSpPr>
+        <p:spPr>
+          <a:xfrm>
+            <a:off x="3884613" y="8685213"/>
+            <a:ext cx="2971800" cy="458787"/>
+          </a:xfrm>
+          <a:prstGeom prst="rect">
+            <a:avLst/>
+          </a:prstGeom>
+        </p:spPr>
+        <p:txBody>
+          <a:bodyPr vert="horz" lIns="91440" tIns="45720" rIns="91440" bIns="45720" rtlCol="0" anchor="b"/>
+          <a:lstStyle>
+            <a:lvl1pPr algn="r">
+              <a:defRPr sz="1200"/>
+            </a:lvl1pPr>
+          </a:lstStyle>
+          <a:p>
+            <a:fld id="{71E2E39A-8D9F-4650-848F-D32267EFFA5C}" type="slidenum">
+              <a:rPr lang="ko-KR" altLang="en-US" smtClean="0"/>
+              <a:t>‹#›</a:t>
+            </a:fld>
+            <a:endParaRPr lang="ko-KR" altLang="en-US"/>
+          </a:p>
+        </p:txBody>
+      </p:sp>
+    </p:spTree>
+    <p:extLst>
+      <p:ext uri="{BB962C8B-B14F-4D97-AF65-F5344CB8AC3E}">
+        <p14:creationId xmlns:p14="http://schemas.microsoft.com/office/powerpoint/2010/main" val="3801399942"/>
+      </p:ext>
+    </p:extLst>
+  </p:cSld>
+  <p:clrMap bg1="lt1" tx1="dk1" bg2="lt2" tx2="dk2" accent1="accent1" accent2="accent2" accent3="accent3" accent4="accent4" accent5="accent5" accent6="accent6" hlink="hlink" folHlink="folHlink"/>
+</p:handoutMaster>
 </file>
 
 <file path=ppt/notesMasters/notesMaster1.xml><?xml version="1.0" encoding="utf-8"?>
@@ -1807,17 +1999,9 @@
               </a:path>
             </a:pathLst>
           </a:custGeom>
-          <a:gradFill>
-            <a:gsLst>
-              <a:gs pos="0">
-                <a:srgbClr val="4BB0A0"/>
-              </a:gs>
-              <a:gs pos="100000">
-                <a:srgbClr val="4BB0A0"/>
-              </a:gs>
-            </a:gsLst>
-            <a:lin ang="2698631" scaled="0"/>
-          </a:gradFill>
+          <a:solidFill>
+            <a:srgbClr val="03426C"/>
+          </a:solidFill>
           <a:ln>
             <a:noFill/>
           </a:ln>
@@ -1842,7 +2026,7 @@
               <a:buFont typeface="Calibri"/>
               <a:buNone/>
             </a:pPr>
-            <a:endParaRPr sz="1800" b="0" i="0" u="none" strike="noStrike" cap="none">
+            <a:endParaRPr sz="1800" b="0" i="0" u="none" strike="noStrike" cap="none" dirty="0">
               <a:solidFill>
                 <a:schemeClr val="dk1"/>
               </a:solidFill>
@@ -1916,17 +2100,9 @@
               </a:path>
             </a:pathLst>
           </a:custGeom>
-          <a:gradFill>
-            <a:gsLst>
-              <a:gs pos="0">
-                <a:srgbClr val="4BB0A0"/>
-              </a:gs>
-              <a:gs pos="100000">
-                <a:srgbClr val="52AEE1"/>
-              </a:gs>
-            </a:gsLst>
-            <a:lin ang="2698631" scaled="0"/>
-          </a:gradFill>
+          <a:solidFill>
+            <a:srgbClr val="FD7605"/>
+          </a:solidFill>
           <a:ln>
             <a:noFill/>
           </a:ln>
@@ -2403,17 +2579,9 @@
               </a:path>
             </a:pathLst>
           </a:custGeom>
-          <a:gradFill>
-            <a:gsLst>
-              <a:gs pos="0">
-                <a:srgbClr val="4BB0A0"/>
-              </a:gs>
-              <a:gs pos="100000">
-                <a:srgbClr val="52AEE1"/>
-              </a:gs>
-            </a:gsLst>
-            <a:lin ang="2698631" scaled="0"/>
-          </a:gradFill>
+          <a:solidFill>
+            <a:srgbClr val="03426C"/>
+          </a:solidFill>
           <a:ln>
             <a:noFill/>
           </a:ln>
@@ -2502,17 +2670,9 @@
               </a:path>
             </a:pathLst>
           </a:custGeom>
-          <a:gradFill>
-            <a:gsLst>
-              <a:gs pos="0">
-                <a:srgbClr val="4BB0A0"/>
-              </a:gs>
-              <a:gs pos="100000">
-                <a:srgbClr val="4BB0A0"/>
-              </a:gs>
-            </a:gsLst>
-            <a:lin ang="2698631" scaled="0"/>
-          </a:gradFill>
+          <a:solidFill>
+            <a:srgbClr val="FD7605"/>
+          </a:solidFill>
           <a:ln>
             <a:noFill/>
           </a:ln>
@@ -2743,7 +2903,7 @@
         </p:nvSpPr>
         <p:spPr>
           <a:xfrm>
-            <a:off x="487015" y="107957"/>
+            <a:off x="487015" y="315796"/>
             <a:ext cx="11281052" cy="671349"/>
           </a:xfrm>
           <a:prstGeom prst="rect">
@@ -3293,17 +3453,9 @@
               </a:path>
             </a:pathLst>
           </a:custGeom>
-          <a:gradFill>
-            <a:gsLst>
-              <a:gs pos="0">
-                <a:srgbClr val="4BB0A0"/>
-              </a:gs>
-              <a:gs pos="100000">
-                <a:srgbClr val="52AEE1"/>
-              </a:gs>
-            </a:gsLst>
-            <a:lin ang="2698631" scaled="0"/>
-          </a:gradFill>
+          <a:solidFill>
+            <a:srgbClr val="03426C"/>
+          </a:solidFill>
           <a:ln>
             <a:noFill/>
           </a:ln>
@@ -3392,17 +3544,9 @@
               </a:path>
             </a:pathLst>
           </a:custGeom>
-          <a:gradFill>
-            <a:gsLst>
-              <a:gs pos="0">
-                <a:srgbClr val="4BB0A0"/>
-              </a:gs>
-              <a:gs pos="100000">
-                <a:srgbClr val="4BB0A0"/>
-              </a:gs>
-            </a:gsLst>
-            <a:lin ang="2698631" scaled="0"/>
-          </a:gradFill>
+          <a:solidFill>
+            <a:srgbClr val="FD7605"/>
+          </a:solidFill>
           <a:ln>
             <a:noFill/>
           </a:ln>
@@ -3451,7 +3595,7 @@
         </p:nvSpPr>
         <p:spPr>
           <a:xfrm>
-            <a:off x="487015" y="107957"/>
+            <a:off x="487015" y="315796"/>
             <a:ext cx="11281052" cy="671349"/>
           </a:xfrm>
           <a:prstGeom prst="rect">
@@ -3579,7 +3723,7 @@
             </a:lvl9pPr>
           </a:lstStyle>
           <a:p>
-            <a:endParaRPr/>
+            <a:endParaRPr dirty="0"/>
           </a:p>
         </p:txBody>
       </p:sp>
@@ -3777,7 +3921,7 @@
         </p:nvSpPr>
         <p:spPr>
           <a:xfrm>
-            <a:off x="487015" y="815008"/>
+            <a:off x="487015" y="1022847"/>
             <a:ext cx="11281052" cy="2186609"/>
           </a:xfrm>
           <a:prstGeom prst="rect">
@@ -4185,17 +4329,9 @@
               </a:path>
             </a:pathLst>
           </a:custGeom>
-          <a:gradFill>
-            <a:gsLst>
-              <a:gs pos="0">
-                <a:srgbClr val="4BB0A0"/>
-              </a:gs>
-              <a:gs pos="100000">
-                <a:srgbClr val="52AEE1"/>
-              </a:gs>
-            </a:gsLst>
-            <a:lin ang="2698631" scaled="0"/>
-          </a:gradFill>
+          <a:solidFill>
+            <a:srgbClr val="03426C"/>
+          </a:solidFill>
           <a:ln>
             <a:noFill/>
           </a:ln>
@@ -4869,17 +5005,9 @@
               </a:path>
             </a:pathLst>
           </a:custGeom>
-          <a:gradFill>
-            <a:gsLst>
-              <a:gs pos="0">
-                <a:srgbClr val="4BB0A0"/>
-              </a:gs>
-              <a:gs pos="100000">
-                <a:srgbClr val="4BB0A0"/>
-              </a:gs>
-            </a:gsLst>
-            <a:lin ang="2698631" scaled="0"/>
-          </a:gradFill>
+          <a:solidFill>
+            <a:srgbClr val="FD7605"/>
+          </a:solidFill>
           <a:ln>
             <a:noFill/>
           </a:ln>
@@ -5659,7 +5787,7 @@
         </p:nvSpPr>
         <p:spPr>
           <a:xfrm>
-            <a:off x="487015" y="107957"/>
+            <a:off x="487015" y="311876"/>
             <a:ext cx="11281052" cy="671349"/>
           </a:xfrm>
           <a:prstGeom prst="rect">
@@ -5787,7 +5915,7 @@
             </a:lvl9pPr>
           </a:lstStyle>
           <a:p>
-            <a:endParaRPr/>
+            <a:endParaRPr dirty="0"/>
           </a:p>
         </p:txBody>
       </p:sp>
@@ -5796,7 +5924,7 @@
   <p:clrMapOvr>
     <a:masterClrMapping/>
   </p:clrMapOvr>
-  <p:extLst>
+  <p:extLst mod="1">
     <p:ext uri="{DCECCB84-F9BA-43D5-87BE-67443E8EF086}">
       <p15:sldGuideLst xmlns:p15="http://schemas.microsoft.com/office/powerpoint/2012/main">
         <p15:guide id="1" orient="horz" pos="2160">
@@ -5894,17 +6022,9 @@
               </a:path>
             </a:pathLst>
           </a:custGeom>
-          <a:gradFill>
-            <a:gsLst>
-              <a:gs pos="0">
-                <a:srgbClr val="4BB0A0"/>
-              </a:gs>
-              <a:gs pos="100000">
-                <a:srgbClr val="52AEE1"/>
-              </a:gs>
-            </a:gsLst>
-            <a:lin ang="2698631" scaled="0"/>
-          </a:gradFill>
+          <a:solidFill>
+            <a:srgbClr val="03426C"/>
+          </a:solidFill>
           <a:ln>
             <a:noFill/>
           </a:ln>
@@ -5993,17 +6113,9 @@
               </a:path>
             </a:pathLst>
           </a:custGeom>
-          <a:gradFill>
-            <a:gsLst>
-              <a:gs pos="0">
-                <a:srgbClr val="4BB0A0"/>
-              </a:gs>
-              <a:gs pos="100000">
-                <a:srgbClr val="4BB0A0"/>
-              </a:gs>
-            </a:gsLst>
-            <a:lin ang="2698631" scaled="0"/>
-          </a:gradFill>
+          <a:solidFill>
+            <a:srgbClr val="FD7605"/>
+          </a:solidFill>
           <a:ln>
             <a:noFill/>
           </a:ln>
@@ -6052,7 +6164,7 @@
         </p:nvSpPr>
         <p:spPr>
           <a:xfrm>
-            <a:off x="487015" y="107957"/>
+            <a:off x="487015" y="315796"/>
             <a:ext cx="11281052" cy="671349"/>
           </a:xfrm>
           <a:prstGeom prst="rect">
@@ -6378,7 +6490,7 @@
         </p:nvSpPr>
         <p:spPr>
           <a:xfrm>
-            <a:off x="487015" y="815009"/>
+            <a:off x="487015" y="1022848"/>
             <a:ext cx="11281052" cy="781242"/>
           </a:xfrm>
           <a:prstGeom prst="rect">
@@ -8116,6 +8228,36 @@
           </a:p>
         </p:txBody>
       </p:sp>
+      <p:pic>
+        <p:nvPicPr>
+          <p:cNvPr id="7" name="그림 6">
+            <a:extLst>
+              <a:ext uri="{FF2B5EF4-FFF2-40B4-BE49-F238E27FC236}">
+                <a16:creationId xmlns:a16="http://schemas.microsoft.com/office/drawing/2014/main" id="{16D3643E-C6E2-4268-93FA-5F5FA201213C}"/>
+              </a:ext>
+            </a:extLst>
+          </p:cNvPr>
+          <p:cNvPicPr>
+            <a:picLocks noChangeAspect="1"/>
+          </p:cNvPicPr>
+          <p:nvPr userDrawn="1"/>
+        </p:nvPicPr>
+        <p:blipFill>
+          <a:blip r:embed="rId7"/>
+          <a:stretch>
+            <a:fillRect/>
+          </a:stretch>
+        </p:blipFill>
+        <p:spPr>
+          <a:xfrm>
+            <a:off x="9829239" y="104349"/>
+            <a:ext cx="2173371" cy="747096"/>
+          </a:xfrm>
+          <a:prstGeom prst="rect">
+            <a:avLst/>
+          </a:prstGeom>
+        </p:spPr>
+      </p:pic>
     </p:spTree>
   </p:cSld>
   <p:clrMap bg1="lt1" tx1="dk1" bg2="dk2" tx2="lt2" accent1="accent1" accent2="accent2" accent3="accent3" accent4="accent4" accent5="accent5" accent6="accent6" hlink="hlink" folHlink="folHlink"/>
@@ -8996,7 +9138,7 @@
         </p:nvSpPr>
         <p:spPr>
           <a:xfrm>
-            <a:off x="1020350" y="851445"/>
+            <a:off x="871933" y="851445"/>
             <a:ext cx="8816005" cy="369332"/>
           </a:xfrm>
           <a:prstGeom prst="rect">
@@ -9023,9 +9165,9 @@
               <a:buNone/>
             </a:pPr>
             <a:r>
-              <a:rPr lang="ko-KR" sz="1800" b="0" i="0" u="none" strike="noStrike" cap="none">
-                <a:solidFill>
-                  <a:schemeClr val="dk1"/>
+              <a:rPr lang="ko-KR" sz="1800" b="0" i="0" u="none" strike="noStrike" cap="none" dirty="0">
+                <a:solidFill>
+                  <a:schemeClr val="bg1"/>
                 </a:solidFill>
                 <a:latin typeface="Calibri"/>
                 <a:ea typeface="Calibri"/>
@@ -9037,7 +9179,7 @@
             <a:r>
               <a:rPr lang="en-US" altLang="ko-KR" sz="1800" b="0" i="0" u="none" strike="noStrike" cap="none" dirty="0">
                 <a:solidFill>
-                  <a:schemeClr val="dk1"/>
+                  <a:schemeClr val="bg1"/>
                 </a:solidFill>
                 <a:latin typeface="Calibri"/>
                 <a:ea typeface="Calibri"/>
@@ -9049,7 +9191,7 @@
             <a:r>
               <a:rPr lang="ko-KR" sz="1800" b="0" i="0" u="none" strike="noStrike" cap="none" dirty="0">
                 <a:solidFill>
-                  <a:schemeClr val="dk1"/>
+                  <a:schemeClr val="bg1"/>
                 </a:solidFill>
                 <a:latin typeface="Calibri"/>
                 <a:ea typeface="Calibri"/>
@@ -9060,7 +9202,7 @@
             </a:r>
             <a:endParaRPr sz="1800" dirty="0">
               <a:solidFill>
-                <a:schemeClr val="dk1"/>
+                <a:schemeClr val="bg1"/>
               </a:solidFill>
               <a:latin typeface="Calibri"/>
               <a:ea typeface="Calibri"/>
@@ -9107,7 +9249,7 @@
         </p:nvSpPr>
         <p:spPr>
           <a:xfrm>
-            <a:off x="487015" y="107957"/>
+            <a:off x="487015" y="367513"/>
             <a:ext cx="11281052" cy="671349"/>
           </a:xfrm>
           <a:prstGeom prst="rect">
@@ -9729,7 +9871,7 @@
         </p:nvSpPr>
         <p:spPr>
           <a:xfrm>
-            <a:off x="487015" y="107957"/>
+            <a:off x="487015" y="316539"/>
             <a:ext cx="11281052" cy="671349"/>
           </a:xfrm>
           <a:prstGeom prst="rect">
@@ -9764,16 +9906,12 @@
               <a:buNone/>
             </a:pPr>
             <a:r>
-              <a:rPr lang="ko-KR" altLang="en-US"/>
+              <a:rPr lang="ko-KR" altLang="en-US" dirty="0"/>
               <a:t>인공지능 강의</a:t>
             </a:r>
             <a:r>
-              <a:rPr lang="ko-KR"/>
-              <a:t> </a:t>
-            </a:r>
-            <a:r>
               <a:rPr lang="ko-KR" dirty="0"/>
-              <a:t>학습 목표</a:t>
+              <a:t> 학습 목표</a:t>
             </a:r>
             <a:endParaRPr dirty="0"/>
           </a:p>
@@ -9787,7 +9925,7 @@
         </p:nvSpPr>
         <p:spPr>
           <a:xfrm>
-            <a:off x="487015" y="908845"/>
+            <a:off x="487015" y="1080282"/>
             <a:ext cx="5183535" cy="5402912"/>
           </a:xfrm>
           <a:prstGeom prst="rect">
@@ -10291,7 +10429,7 @@
         </p:nvSpPr>
         <p:spPr>
           <a:xfrm>
-            <a:off x="5875959" y="652214"/>
+            <a:off x="5875959" y="823651"/>
             <a:ext cx="6108700" cy="5553572"/>
           </a:xfrm>
           <a:prstGeom prst="rect">
@@ -10965,7 +11103,7 @@
         </p:nvSpPr>
         <p:spPr>
           <a:xfrm>
-            <a:off x="487015" y="107957"/>
+            <a:off x="487015" y="378711"/>
             <a:ext cx="11281052" cy="671349"/>
           </a:xfrm>
           <a:prstGeom prst="rect">
@@ -11465,7 +11603,7 @@
         </p:blipFill>
         <p:spPr>
           <a:xfrm>
-            <a:off x="7127572" y="633545"/>
+            <a:off x="5689390" y="881399"/>
             <a:ext cx="3955211" cy="5590909"/>
           </a:xfrm>
           <a:prstGeom prst="rect">
@@ -11520,7 +11658,7 @@
         </p:nvSpPr>
         <p:spPr>
           <a:xfrm>
-            <a:off x="487015" y="107957"/>
+            <a:off x="487015" y="367513"/>
             <a:ext cx="11281052" cy="671349"/>
           </a:xfrm>
           <a:prstGeom prst="rect">
@@ -12789,7 +12927,7 @@
         </p:nvSpPr>
         <p:spPr>
           <a:xfrm>
-            <a:off x="487015" y="107957"/>
+            <a:off x="487015" y="408650"/>
             <a:ext cx="11281052" cy="671349"/>
           </a:xfrm>
           <a:prstGeom prst="rect">
@@ -13403,7 +13541,7 @@
         </p:nvSpPr>
         <p:spPr>
           <a:xfrm>
-            <a:off x="487015" y="107957"/>
+            <a:off x="487015" y="408651"/>
             <a:ext cx="11281052" cy="671349"/>
           </a:xfrm>
           <a:prstGeom prst="rect">
@@ -13503,7 +13641,7 @@
         </p:nvSpPr>
         <p:spPr>
           <a:xfrm>
-            <a:off x="468000" y="1080000"/>
+            <a:off x="468000" y="1168777"/>
             <a:ext cx="11624609" cy="5074812"/>
           </a:xfrm>
           <a:prstGeom prst="rect">
@@ -14368,4 +14506,299 @@
   <a:objectDefaults/>
   <a:extraClrSchemeLst/>
 </a:theme>
+</file>
+
+<file path=ppt/theme/theme3.xml><?xml version="1.0" encoding="utf-8"?>
+<a:theme xmlns:a="http://schemas.openxmlformats.org/drawingml/2006/main" name="Office 테마">
+  <a:themeElements>
+    <a:clrScheme name="Office">
+      <a:dk1>
+        <a:sysClr val="windowText" lastClr="000000"/>
+      </a:dk1>
+      <a:lt1>
+        <a:sysClr val="window" lastClr="FFFFFF"/>
+      </a:lt1>
+      <a:dk2>
+        <a:srgbClr val="44546A"/>
+      </a:dk2>
+      <a:lt2>
+        <a:srgbClr val="E7E6E6"/>
+      </a:lt2>
+      <a:accent1>
+        <a:srgbClr val="4472C4"/>
+      </a:accent1>
+      <a:accent2>
+        <a:srgbClr val="ED7D31"/>
+      </a:accent2>
+      <a:accent3>
+        <a:srgbClr val="A5A5A5"/>
+      </a:accent3>
+      <a:accent4>
+        <a:srgbClr val="FFC000"/>
+      </a:accent4>
+      <a:accent5>
+        <a:srgbClr val="5B9BD5"/>
+      </a:accent5>
+      <a:accent6>
+        <a:srgbClr val="70AD47"/>
+      </a:accent6>
+      <a:hlink>
+        <a:srgbClr val="0563C1"/>
+      </a:hlink>
+      <a:folHlink>
+        <a:srgbClr val="954F72"/>
+      </a:folHlink>
+    </a:clrScheme>
+    <a:fontScheme name="Office">
+      <a:majorFont>
+        <a:latin typeface="맑은 고딕" panose="020F0302020204030204"/>
+        <a:ea typeface=""/>
+        <a:cs typeface=""/>
+        <a:font script="Jpan" typeface="游ゴシック Light"/>
+        <a:font script="Hang" typeface="맑은 고딕"/>
+        <a:font script="Hans" typeface="等线 Light"/>
+        <a:font script="Hant" typeface="新細明體"/>
+        <a:font script="Arab" typeface="Times New Roman"/>
+        <a:font script="Hebr" typeface="Times New Roman"/>
+        <a:font script="Thai" typeface="Angsana New"/>
+        <a:font script="Ethi" typeface="Nyala"/>
+        <a:font script="Beng" typeface="Vrinda"/>
+        <a:font script="Gujr" typeface="Shruti"/>
+        <a:font script="Khmr" typeface="MoolBoran"/>
+        <a:font script="Knda" typeface="Tunga"/>
+        <a:font script="Guru" typeface="Raavi"/>
+        <a:font script="Cans" typeface="Euphemia"/>
+        <a:font script="Cher" typeface="Plantagenet Cherokee"/>
+        <a:font script="Yiii" typeface="Microsoft Yi Baiti"/>
+        <a:font script="Tibt" typeface="Microsoft Himalaya"/>
+        <a:font script="Thaa" typeface="MV Boli"/>
+        <a:font script="Deva" typeface="Mangal"/>
+        <a:font script="Telu" typeface="Gautami"/>
+        <a:font script="Taml" typeface="Latha"/>
+        <a:font script="Syrc" typeface="Estrangelo Edessa"/>
+        <a:font script="Orya" typeface="Kalinga"/>
+        <a:font script="Mlym" typeface="Kartika"/>
+        <a:font script="Laoo" typeface="DokChampa"/>
+        <a:font script="Sinh" typeface="Iskoola Pota"/>
+        <a:font script="Mong" typeface="Mongolian Baiti"/>
+        <a:font script="Viet" typeface="Times New Roman"/>
+        <a:font script="Uigh" typeface="Microsoft Uighur"/>
+        <a:font script="Geor" typeface="Sylfaen"/>
+        <a:font script="Armn" typeface="Arial"/>
+        <a:font script="Bugi" typeface="Leelawadee UI"/>
+        <a:font script="Bopo" typeface="Microsoft JhengHei"/>
+        <a:font script="Java" typeface="Javanese Text"/>
+        <a:font script="Lisu" typeface="Segoe UI"/>
+        <a:font script="Mymr" typeface="Myanmar Text"/>
+        <a:font script="Nkoo" typeface="Ebrima"/>
+        <a:font script="Olck" typeface="Nirmala UI"/>
+        <a:font script="Osma" typeface="Ebrima"/>
+        <a:font script="Phag" typeface="Phagspa"/>
+        <a:font script="Syrn" typeface="Estrangelo Edessa"/>
+        <a:font script="Syrj" typeface="Estrangelo Edessa"/>
+        <a:font script="Syre" typeface="Estrangelo Edessa"/>
+        <a:font script="Sora" typeface="Nirmala UI"/>
+        <a:font script="Tale" typeface="Microsoft Tai Le"/>
+        <a:font script="Talu" typeface="Microsoft New Tai Lue"/>
+        <a:font script="Tfng" typeface="Ebrima"/>
+      </a:majorFont>
+      <a:minorFont>
+        <a:latin typeface="맑은 고딕" panose="020F0502020204030204"/>
+        <a:ea typeface=""/>
+        <a:cs typeface=""/>
+        <a:font script="Jpan" typeface="游ゴシック"/>
+        <a:font script="Hang" typeface="맑은 고딕"/>
+        <a:font script="Hans" typeface="等线"/>
+        <a:font script="Hant" typeface="新細明體"/>
+        <a:font script="Arab" typeface="Arial"/>
+        <a:font script="Hebr" typeface="Arial"/>
+        <a:font script="Thai" typeface="Cordia New"/>
+        <a:font script="Ethi" typeface="Nyala"/>
+        <a:font script="Beng" typeface="Vrinda"/>
+        <a:font script="Gujr" typeface="Shruti"/>
+        <a:font script="Khmr" typeface="DaunPenh"/>
+        <a:font script="Knda" typeface="Tunga"/>
+        <a:font script="Guru" typeface="Raavi"/>
+        <a:font script="Cans" typeface="Euphemia"/>
+        <a:font script="Cher" typeface="Plantagenet Cherokee"/>
+        <a:font script="Yiii" typeface="Microsoft Yi Baiti"/>
+        <a:font script="Tibt" typeface="Microsoft Himalaya"/>
+        <a:font script="Thaa" typeface="MV Boli"/>
+        <a:font script="Deva" typeface="Mangal"/>
+        <a:font script="Telu" typeface="Gautami"/>
+        <a:font script="Taml" typeface="Latha"/>
+        <a:font script="Syrc" typeface="Estrangelo Edessa"/>
+        <a:font script="Orya" typeface="Kalinga"/>
+        <a:font script="Mlym" typeface="Kartika"/>
+        <a:font script="Laoo" typeface="DokChampa"/>
+        <a:font script="Sinh" typeface="Iskoola Pota"/>
+        <a:font script="Mong" typeface="Mongolian Baiti"/>
+        <a:font script="Viet" typeface="Arial"/>
+        <a:font script="Uigh" typeface="Microsoft Uighur"/>
+        <a:font script="Geor" typeface="Sylfaen"/>
+        <a:font script="Armn" typeface="Arial"/>
+        <a:font script="Bugi" typeface="Leelawadee UI"/>
+        <a:font script="Bopo" typeface="Microsoft JhengHei"/>
+        <a:font script="Java" typeface="Javanese Text"/>
+        <a:font script="Lisu" typeface="Segoe UI"/>
+        <a:font script="Mymr" typeface="Myanmar Text"/>
+        <a:font script="Nkoo" typeface="Ebrima"/>
+        <a:font script="Olck" typeface="Nirmala UI"/>
+        <a:font script="Osma" typeface="Ebrima"/>
+        <a:font script="Phag" typeface="Phagspa"/>
+        <a:font script="Syrn" typeface="Estrangelo Edessa"/>
+        <a:font script="Syrj" typeface="Estrangelo Edessa"/>
+        <a:font script="Syre" typeface="Estrangelo Edessa"/>
+        <a:font script="Sora" typeface="Nirmala UI"/>
+        <a:font script="Tale" typeface="Microsoft Tai Le"/>
+        <a:font script="Talu" typeface="Microsoft New Tai Lue"/>
+        <a:font script="Tfng" typeface="Ebrima"/>
+      </a:minorFont>
+    </a:fontScheme>
+    <a:fmtScheme name="Office">
+      <a:fillStyleLst>
+        <a:solidFill>
+          <a:schemeClr val="phClr"/>
+        </a:solidFill>
+        <a:gradFill rotWithShape="1">
+          <a:gsLst>
+            <a:gs pos="0">
+              <a:schemeClr val="phClr">
+                <a:lumMod val="110000"/>
+                <a:satMod val="105000"/>
+                <a:tint val="67000"/>
+              </a:schemeClr>
+            </a:gs>
+            <a:gs pos="50000">
+              <a:schemeClr val="phClr">
+                <a:lumMod val="105000"/>
+                <a:satMod val="103000"/>
+                <a:tint val="73000"/>
+              </a:schemeClr>
+            </a:gs>
+            <a:gs pos="100000">
+              <a:schemeClr val="phClr">
+                <a:lumMod val="105000"/>
+                <a:satMod val="109000"/>
+                <a:tint val="81000"/>
+              </a:schemeClr>
+            </a:gs>
+          </a:gsLst>
+          <a:lin ang="5400000" scaled="0"/>
+        </a:gradFill>
+        <a:gradFill rotWithShape="1">
+          <a:gsLst>
+            <a:gs pos="0">
+              <a:schemeClr val="phClr">
+                <a:satMod val="103000"/>
+                <a:lumMod val="102000"/>
+                <a:tint val="94000"/>
+              </a:schemeClr>
+            </a:gs>
+            <a:gs pos="50000">
+              <a:schemeClr val="phClr">
+                <a:satMod val="110000"/>
+                <a:lumMod val="100000"/>
+                <a:shade val="100000"/>
+              </a:schemeClr>
+            </a:gs>
+            <a:gs pos="100000">
+              <a:schemeClr val="phClr">
+                <a:lumMod val="99000"/>
+                <a:satMod val="120000"/>
+                <a:shade val="78000"/>
+              </a:schemeClr>
+            </a:gs>
+          </a:gsLst>
+          <a:lin ang="5400000" scaled="0"/>
+        </a:gradFill>
+      </a:fillStyleLst>
+      <a:lnStyleLst>
+        <a:ln w="6350" cap="flat" cmpd="sng" algn="ctr">
+          <a:solidFill>
+            <a:schemeClr val="phClr"/>
+          </a:solidFill>
+          <a:prstDash val="solid"/>
+          <a:miter lim="800000"/>
+        </a:ln>
+        <a:ln w="12700" cap="flat" cmpd="sng" algn="ctr">
+          <a:solidFill>
+            <a:schemeClr val="phClr"/>
+          </a:solidFill>
+          <a:prstDash val="solid"/>
+          <a:miter lim="800000"/>
+        </a:ln>
+        <a:ln w="19050" cap="flat" cmpd="sng" algn="ctr">
+          <a:solidFill>
+            <a:schemeClr val="phClr"/>
+          </a:solidFill>
+          <a:prstDash val="solid"/>
+          <a:miter lim="800000"/>
+        </a:ln>
+      </a:lnStyleLst>
+      <a:effectStyleLst>
+        <a:effectStyle>
+          <a:effectLst/>
+        </a:effectStyle>
+        <a:effectStyle>
+          <a:effectLst/>
+        </a:effectStyle>
+        <a:effectStyle>
+          <a:effectLst>
+            <a:outerShdw blurRad="57150" dist="19050" dir="5400000" algn="ctr" rotWithShape="0">
+              <a:srgbClr val="000000">
+                <a:alpha val="63000"/>
+              </a:srgbClr>
+            </a:outerShdw>
+          </a:effectLst>
+        </a:effectStyle>
+      </a:effectStyleLst>
+      <a:bgFillStyleLst>
+        <a:solidFill>
+          <a:schemeClr val="phClr"/>
+        </a:solidFill>
+        <a:solidFill>
+          <a:schemeClr val="phClr">
+            <a:tint val="95000"/>
+            <a:satMod val="170000"/>
+          </a:schemeClr>
+        </a:solidFill>
+        <a:gradFill rotWithShape="1">
+          <a:gsLst>
+            <a:gs pos="0">
+              <a:schemeClr val="phClr">
+                <a:tint val="93000"/>
+                <a:satMod val="150000"/>
+                <a:shade val="98000"/>
+                <a:lumMod val="102000"/>
+              </a:schemeClr>
+            </a:gs>
+            <a:gs pos="50000">
+              <a:schemeClr val="phClr">
+                <a:tint val="98000"/>
+                <a:satMod val="130000"/>
+                <a:shade val="90000"/>
+                <a:lumMod val="103000"/>
+              </a:schemeClr>
+            </a:gs>
+            <a:gs pos="100000">
+              <a:schemeClr val="phClr">
+                <a:shade val="63000"/>
+                <a:satMod val="120000"/>
+              </a:schemeClr>
+            </a:gs>
+          </a:gsLst>
+          <a:lin ang="5400000" scaled="0"/>
+        </a:gradFill>
+      </a:bgFillStyleLst>
+    </a:fmtScheme>
+  </a:themeElements>
+  <a:objectDefaults/>
+  <a:extraClrSchemeLst/>
+  <a:extLst>
+    <a:ext uri="{05A4C25C-085E-4340-85A3-A5531E510DB2}">
+      <thm15:themeFamily xmlns:thm15="http://schemas.microsoft.com/office/thememl/2012/main" name="Office Theme" id="{62F939B6-93AF-4DB8-9C6B-D6C7DFDC589F}" vid="{4A3C46E8-61CC-4603-A589-7422A47A8E4A}"/>
+    </a:ext>
+  </a:extLst>
+</a:theme>
 </file>
</xml_diff>